<commit_message>
Fill group-split results (3 seeds) in decks, scripts and report; rename progress deck
Co-Authored-By: Claude Sonnet 5.5 <noreply@anthropic.com>
Claude-Session: https://claude.ai/code/session_01Mrmk7xtGXEASaZHBUGuSEF
</commit_message>
<xml_diff>
--- a/DR_5min_Progress.pptx
+++ b/DR_5min_Progress.pptx
@@ -20511,7 +20511,7 @@
                 </a:solidFill>
                 <a:latin typeface="Arial"/>
               </a:rPr>
-              <a:t>• Checks: duplicates, image properties, augmentation; group DDR split built and arms retrained (1 seed) and evaluated</a:t>
+              <a:t>• Checks: duplicates, image properties, augmentation; group DDR split built and arms retrained (3 seeds) and evaluated</a:t>
             </a:r>
           </a:p>
         </p:txBody>
@@ -20579,7 +20579,7 @@
                 </a:solidFill>
                 <a:latin typeface="Arial"/>
               </a:rPr>
-              <a:t>• Group-split models evaluated once: no test result changed beyond seed noise</a:t>
+              <a:t>• Group-split models evaluated over 3 seeds: AUROC changed by at most 0.003 on DDR and APTOS</a:t>
             </a:r>
           </a:p>
           <a:p>

</xml_diff>

<commit_message>
Add ECE, Brier and 95% intervals (3 seeds) to decks, report and scripts
Co-Authored-By: Claude Sonnet 5.5 <noreply@anthropic.com>
Claude-Session: https://claude.ai/code/session_01Mrmk7xtGXEASaZHBUGuSEF
</commit_message>
<xml_diff>
--- a/DR_5min_Progress.pptx
+++ b/DR_5min_Progress.pptx
@@ -20671,7 +20671,7 @@
                 </a:solidFill>
                 <a:latin typeface="Arial"/>
               </a:rPr>
-              <a:t>• Report AUROC, per-grade results and own-source operating points</a:t>
+              <a:t>• Own-source operating points (post-hoc)</a:t>
             </a:r>
           </a:p>
           <a:p>
@@ -20695,7 +20695,7 @@
                 </a:solidFill>
                 <a:latin typeface="Arial"/>
               </a:rPr>
-              <a:t>• Five seeds, intervals, ECE, Brier</a:t>
+              <a:t>• Literature search</a:t>
             </a:r>
           </a:p>
           <a:p>
@@ -21973,7 +21973,7 @@
                 </a:solidFill>
                 <a:latin typeface="Arial"/>
               </a:rPr>
-              <a:t>Not yet reported</a:t>
+              <a:t>Reported and post-hoc</a:t>
             </a:r>
           </a:p>
           <a:p>
@@ -21985,7 +21985,7 @@
                 </a:solidFill>
                 <a:latin typeface="Arial"/>
               </a:rPr>
-              <a:t>Confidence intervals, ECE, Brier and five seeds. Per-grade and specificity analyses are post-hoc.</a:t>
+              <a:t>Group-split results have 95% intervals, ECE and Brier over 3 seeds. Per-grade, specificity and size-strata analyses are post-hoc.</a:t>
             </a:r>
           </a:p>
         </p:txBody>
@@ -22299,7 +22299,7 @@
                 </a:solidFill>
                 <a:latin typeface="Arial"/>
               </a:rPr>
-              <a:t>Arm B: EyePACS specificity 0.89, AUROC 0.88; DDR sensitivity unchanged.</a:t>
+              <a:t>Arm B: EyePACS AUROC 0.884 (0.870-0.897), specificity 0.90, ECE 0.056 vs 0.326 (A) and 0.717 (C).</a:t>
             </a:r>
           </a:p>
         </p:txBody>
@@ -22469,7 +22469,7 @@
                 </a:solidFill>
                 <a:latin typeface="Arial"/>
               </a:rPr>
-              <a:t>4. Five seeds on the group split, intervals, ECE and Brier</a:t>
+              <a:t>4. More seeds only if needed: the spread over 3 seeds is small</a:t>
             </a:r>
           </a:p>
           <a:p>

</xml_diff>